<commit_message>
fix: update Chiron presentation slides for clarity and consistency
</commit_message>
<xml_diff>
--- a/outputs/chiron-report/Chiron-课程项目汇报.pptx
+++ b/outputs/chiron-report/Chiron-课程项目汇报.pptx
@@ -5944,6 +5944,10 @@
             <a:avLst/>
           </a:prstGeom>
         </p:spPr>
+        <p:txBody>
+          <a:bodyPr/>
+          <a:p/>
+        </p:txBody>
       </p:sp>
       <p:sp>
         <p:nvSpPr>
@@ -6013,6 +6017,10 @@
             <a:avLst/>
           </a:prstGeom>
         </p:spPr>
+        <p:txBody>
+          <a:bodyPr/>
+          <a:p/>
+        </p:txBody>
       </p:sp>
       <p:sp>
         <p:nvSpPr>
@@ -6176,6 +6184,10 @@
             <a:avLst/>
           </a:prstGeom>
         </p:spPr>
+        <p:txBody>
+          <a:bodyPr/>
+          <a:p/>
+        </p:txBody>
       </p:sp>
       <p:sp>
         <p:nvSpPr>
@@ -6279,6 +6291,10 @@
             <a:avLst/>
           </a:prstGeom>
         </p:spPr>
+        <p:txBody>
+          <a:bodyPr/>
+          <a:p/>
+        </p:txBody>
       </p:sp>
       <p:sp>
         <p:nvSpPr>
@@ -6348,6 +6364,10 @@
             <a:avLst/>
           </a:prstGeom>
         </p:spPr>
+        <p:txBody>
+          <a:bodyPr/>
+          <a:p/>
+        </p:txBody>
       </p:sp>
       <p:sp>
         <p:nvSpPr>
@@ -6530,6 +6550,10 @@
             <a:avLst/>
           </a:prstGeom>
         </p:spPr>
+        <p:txBody>
+          <a:bodyPr/>
+          <a:p/>
+        </p:txBody>
       </p:sp>
       <p:sp>
         <p:nvSpPr>
@@ -6747,6 +6771,131 @@
                 </a:solidFill>
               </a:rPr>
               <a:t>因为 LLM 无法区分「语法正确的交易」和「语义错误的交易」。</a:t>
+            </a:r>
+          </a:p>
+        </p:txBody>
+      </p:sp>
+      <p:sp>
+        <p:nvSpPr>
+          <p:cNvPr id="17" name="Rectangle 16"/>
+          <p:cNvSpPr/>
+          <p:nvPr/>
+        </p:nvSpPr>
+        <p:spPr>
+          <a:xfrm>
+            <a:off x="571500" y="1850000"/>
+            <a:ext cx="11049000" cy="600000"/>
+          </a:xfrm>
+          <a:prstGeom prst="rect">
+            <a:avLst/>
+          </a:prstGeom>
+          <a:solidFill>
+            <a:srgbClr val="FFF8E1"/>
+          </a:solidFill>
+          <a:ln w="6350">
+            <a:solidFill>
+              <a:srgbClr val="D4A72C"/>
+            </a:solidFill>
+          </a:ln>
+        </p:spPr>
+        <p:style>
+          <a:lnRef idx="1">
+            <a:schemeClr val="accent1"/>
+          </a:lnRef>
+          <a:fillRef idx="3">
+            <a:schemeClr val="accent1"/>
+          </a:fillRef>
+          <a:effectRef idx="2">
+            <a:schemeClr val="accent1"/>
+          </a:effectRef>
+          <a:fontRef idx="minor">
+            <a:schemeClr val="lt1"/>
+          </a:fontRef>
+        </p:style>
+        <p:txBody>
+          <a:bodyPr rtlCol="0" anchor="ctr"/>
+          <a:lstStyle/>
+          <a:p>
+            <a:pPr algn="ctr"/>
+          </a:p>
+        </p:txBody>
+      </p:sp>
+      <p:sp>
+        <p:nvSpPr>
+          <p:cNvPr id="18" name="TextBox 17"/>
+          <p:cNvSpPr txBox="1"/>
+          <p:nvPr/>
+        </p:nvSpPr>
+        <p:spPr>
+          <a:xfrm>
+            <a:off x="714375" y="1870000"/>
+            <a:ext cx="10763250" cy="560000"/>
+          </a:xfrm>
+          <a:prstGeom prst="rect">
+            <a:avLst/>
+          </a:prstGeom>
+          <a:noFill/>
+        </p:spPr>
+        <p:txBody>
+          <a:bodyPr wrap="square">
+            <a:spAutoFit/>
+          </a:bodyPr>
+          <a:lstStyle/>
+          <a:p>
+            <a:pPr>
+              <a:defRPr sz="1100" b="1">
+                <a:solidFill>
+                  <a:srgbClr val="7A5C00"/>
+                </a:solidFill>
+              </a:defRPr>
+            </a:pPr>
+            <a:r>
+              <a:t>② LLM 读取链上数据并构建 calldata（受害者入口）</a:t>
+            </a:r>
+          </a:p>
+          <a:p>
+            <a:pPr>
+              <a:spcBef>
+                <a:spcPts val="400"/>
+              </a:spcBef>
+              <a:defRPr sz="1000">
+                <a:solidFill>
+                  <a:srgbClr val="656D76"/>
+                </a:solidFill>
+              </a:defRPr>
+            </a:pPr>
+            <a:r>
+              <a:t>Agent 的 LLM 在执行决策时，需要读取链上数据来获取价格、池子地址等参数。</a:t>
+            </a:r>
+          </a:p>
+          <a:p>
+            <a:pPr>
+              <a:spcBef>
+                <a:spcPts val="200"/>
+              </a:spcBef>
+              <a:defRPr sz="1000">
+                <a:solidFill>
+                  <a:srgbClr val="656D76"/>
+                </a:solidFill>
+              </a:defRPr>
+            </a:pPr>
+            <a:r>
+              <a:t>攻击者将恶意指令嵌入这些链上数据中，LLM 无法区分数据和指令，</a:t>
+            </a:r>
+          </a:p>
+          <a:p>
+            <a:pPr>
+              <a:spcBef>
+                <a:spcPts val="200"/>
+              </a:spcBef>
+              <a:defRPr sz="1000">
+                <a:solidFill>
+                  <a:srgbClr val="656D76"/>
+                </a:solidFill>
+              </a:defRPr>
+            </a:pPr>
+            <a:r>
+              <a:t>在构造交易时被注入，签出了和预期完全不同的 calldata。</a:t>
             </a:r>
           </a:p>
         </p:txBody>

</xml_diff>

<commit_message>
feat: add Chiron end-to-end demo scripts and update DeepSeek API integration
</commit_message>
<xml_diff>
--- a/outputs/chiron-report/Chiron-课程项目汇报.pptx
+++ b/outputs/chiron-report/Chiron-课程项目汇报.pptx
@@ -19,8 +19,8 @@
     <p:sldId id="265" r:id="rId10"/>
     <p:sldId id="266" r:id="rId11"/>
     <p:sldId id="267" r:id="rId12"/>
-    <p:sldId id="268" r:id="rId13"/>
-    <p:sldId id="269" r:id="rId14"/>
+    <p:sldId id="272" r:id="rId22"/>
+    <p:sldId id="273" r:id="rId23"/>
   </p:sldIdLst>
   <p:sldSz cx="12192000" cy="6858000"/>
   <p:notesSz cx="6858000" cy="9144000"/>
@@ -1266,6 +1266,10 @@
             <a:avLst/>
           </a:prstGeom>
         </p:spPr>
+        <p:txBody>
+          <a:bodyPr/>
+          <a:p/>
+        </p:txBody>
       </p:sp>
       <p:sp>
         <p:nvSpPr>
@@ -1290,6 +1294,10 @@
             <a:avLst/>
           </a:prstGeom>
         </p:spPr>
+        <p:txBody>
+          <a:bodyPr/>
+          <a:p/>
+        </p:txBody>
       </p:sp>
       <p:sp>
         <p:nvSpPr>
@@ -4870,7 +4878,7 @@
 </file>
 
 <file path=ppt/slides/slide12.xml><?xml version="1.0" encoding="utf-8"?>
-<p:sld xmlns:a="http://schemas.openxmlformats.org/drawingml/2006/main" xmlns:r="http://schemas.openxmlformats.org/officeDocument/2006/relationships" xmlns:p="http://schemas.openxmlformats.org/presentationml/2006/main">
+<p:sld xmlns:a="http://schemas.openxmlformats.org/drawingml/2006/main" xmlns:p="http://schemas.openxmlformats.org/presentationml/2006/main" xmlns:r="http://schemas.openxmlformats.org/officeDocument/2006/relationships">
   <p:cSld>
     <p:spTree>
       <p:nvGrpSpPr>
@@ -4878,14 +4886,7 @@
         <p:cNvGrpSpPr/>
         <p:nvPr/>
       </p:nvGrpSpPr>
-      <p:grpSpPr>
-        <a:xfrm>
-          <a:off x="0" y="0"/>
-          <a:ext cx="0" cy="0"/>
-          <a:chOff x="0" y="0"/>
-          <a:chExt cx="0" cy="0"/>
-        </a:xfrm>
-      </p:grpSpPr>
+      <p:grpSpPr/>
       <p:sp>
         <p:nvSpPr>
           <p:cNvPr id="2" name="TextBox 1"/>
@@ -4894,8 +4895,8 @@
         </p:nvSpPr>
         <p:spPr>
           <a:xfrm>
-            <a:off x="571500" y="380000"/>
-            <a:ext cx="11049000" cy="420000"/>
+            <a:off x="571500" y="250000"/>
+            <a:ext cx="11049000" cy="350000"/>
           </a:xfrm>
           <a:prstGeom prst="rect">
             <a:avLst/>
@@ -4916,7 +4917,7 @@
               </a:defRPr>
             </a:pPr>
             <a:r>
-              <a:t>参考文献与论据来源</a:t>
+              <a:t>参考文献</a:t>
             </a:r>
           </a:p>
         </p:txBody>
@@ -4929,8 +4930,8 @@
         </p:nvSpPr>
         <p:spPr>
           <a:xfrm>
-            <a:off x="571500" y="950000"/>
-            <a:ext cx="11049000" cy="320000"/>
+            <a:off x="571500" y="750000"/>
+            <a:ext cx="11049000" cy="310000"/>
           </a:xfrm>
           <a:prstGeom prst="rect">
             <a:avLst/>
@@ -4963,7 +4964,6 @@
           <a:lstStyle/>
           <a:p>
             <a:pPr algn="ctr"/>
-            <a:endParaRPr/>
           </a:p>
         </p:txBody>
       </p:sp>
@@ -4975,8 +4975,8 @@
         </p:nvSpPr>
         <p:spPr>
           <a:xfrm>
-            <a:off x="691500" y="1010000"/>
-            <a:ext cx="10809000" cy="200000"/>
+            <a:off x="651500" y="810000"/>
+            <a:ext cx="10889000" cy="200000"/>
           </a:xfrm>
           <a:prstGeom prst="rect">
             <a:avLst/>
@@ -4990,14 +4990,14 @@
           <a:lstStyle/>
           <a:p>
             <a:pPr>
-              <a:defRPr sz="1100" b="0">
-                <a:solidFill>
-                  <a:srgbClr val="1F2328"/>
-                </a:solidFill>
-              </a:defRPr>
-            </a:pPr>
-            <a:r>
-              <a:t>[1] arXiv 2601.04583 (2025) — Autonomous Agents on Blockchains</a:t>
+              <a:defRPr sz="1000" b="0">
+                <a:solidFill>
+                  <a:srgbClr val="1F2328"/>
+                </a:solidFill>
+              </a:defRPr>
+            </a:pPr>
+            <a:r>
+              <a:t>[1] "Autonomous Agents on Blockchains." arXiv:2601.04583, 2025.</a:t>
             </a:r>
           </a:p>
         </p:txBody>
@@ -5010,8 +5010,8 @@
         </p:nvSpPr>
         <p:spPr>
           <a:xfrm>
-            <a:off x="571500" y="1310000"/>
-            <a:ext cx="11049000" cy="320000"/>
+            <a:off x="571500" y="1090000"/>
+            <a:ext cx="11049000" cy="310000"/>
           </a:xfrm>
           <a:prstGeom prst="rect">
             <a:avLst/>
@@ -5044,7 +5044,6 @@
           <a:lstStyle/>
           <a:p>
             <a:pPr algn="ctr"/>
-            <a:endParaRPr/>
           </a:p>
         </p:txBody>
       </p:sp>
@@ -5056,8 +5055,8 @@
         </p:nvSpPr>
         <p:spPr>
           <a:xfrm>
-            <a:off x="691500" y="1370000"/>
-            <a:ext cx="10809000" cy="200000"/>
+            <a:off x="651500" y="1150000"/>
+            <a:ext cx="10889000" cy="200000"/>
           </a:xfrm>
           <a:prstGeom prst="rect">
             <a:avLst/>
@@ -5071,14 +5070,14 @@
           <a:lstStyle/>
           <a:p>
             <a:pPr>
-              <a:defRPr sz="1100" b="0">
-                <a:solidFill>
-                  <a:srgbClr val="1F2328"/>
-                </a:solidFill>
-              </a:defRPr>
-            </a:pPr>
-            <a:r>
-              <a:t>[2] Stanford CRFM (2024) — Agent Security and Alignment</a:t>
+              <a:defRPr sz="1000" b="0">
+                <a:solidFill>
+                  <a:srgbClr val="1F2328"/>
+                </a:solidFill>
+              </a:defRPr>
+            </a:pPr>
+            <a:r>
+              <a:t>[2] "Liquidity Exhaustion Attacks on Permissionless DEX." arXiv:2602.17805, 2025.</a:t>
             </a:r>
           </a:p>
         </p:txBody>
@@ -5091,8 +5090,8 @@
         </p:nvSpPr>
         <p:spPr>
           <a:xfrm>
-            <a:off x="571500" y="1670000"/>
-            <a:ext cx="11049000" cy="320000"/>
+            <a:off x="571500" y="1430000"/>
+            <a:ext cx="11049000" cy="310000"/>
           </a:xfrm>
           <a:prstGeom prst="rect">
             <a:avLst/>
@@ -5125,7 +5124,6 @@
           <a:lstStyle/>
           <a:p>
             <a:pPr algn="ctr"/>
-            <a:endParaRPr/>
           </a:p>
         </p:txBody>
       </p:sp>
@@ -5137,8 +5135,8 @@
         </p:nvSpPr>
         <p:spPr>
           <a:xfrm>
-            <a:off x="691500" y="1730000"/>
-            <a:ext cx="10809000" cy="200000"/>
+            <a:off x="651500" y="1490000"/>
+            <a:ext cx="10889000" cy="200000"/>
           </a:xfrm>
           <a:prstGeom prst="rect">
             <a:avLst/>
@@ -5152,14 +5150,14 @@
           <a:lstStyle/>
           <a:p>
             <a:pPr>
-              <a:defRPr sz="1100" b="0">
-                <a:solidFill>
-                  <a:srgbClr val="1F2328"/>
-                </a:solidFill>
-              </a:defRPr>
-            </a:pPr>
-            <a:r>
-              <a:t>[3] arXiv 2403.1114 (2024) — Security of Autonomous Agents</a:t>
+              <a:defRPr sz="1000" b="0">
+                <a:solidFill>
+                  <a:srgbClr val="1F2328"/>
+                </a:solidFill>
+              </a:defRPr>
+            </a:pPr>
+            <a:r>
+              <a:t>[3] Stanford CRFM. "Agent Security and Alignment: Taxonomy of AI Agent Attacks." 2024.</a:t>
             </a:r>
           </a:p>
         </p:txBody>
@@ -5172,8 +5170,8 @@
         </p:nvSpPr>
         <p:spPr>
           <a:xfrm>
-            <a:off x="571500" y="2030000"/>
-            <a:ext cx="11049000" cy="320000"/>
+            <a:off x="571500" y="1770000"/>
+            <a:ext cx="11049000" cy="310000"/>
           </a:xfrm>
           <a:prstGeom prst="rect">
             <a:avLst/>
@@ -5206,7 +5204,6 @@
           <a:lstStyle/>
           <a:p>
             <a:pPr algn="ctr"/>
-            <a:endParaRPr/>
           </a:p>
         </p:txBody>
       </p:sp>
@@ -5218,8 +5215,8 @@
         </p:nvSpPr>
         <p:spPr>
           <a:xfrm>
-            <a:off x="691500" y="2090000"/>
-            <a:ext cx="10809000" cy="200000"/>
+            <a:off x="651500" y="1830000"/>
+            <a:ext cx="10889000" cy="200000"/>
           </a:xfrm>
           <a:prstGeom prst="rect">
             <a:avLst/>
@@ -5233,14 +5230,14 @@
           <a:lstStyle/>
           <a:p>
             <a:pPr>
-              <a:defRPr sz="1100" b="0">
-                <a:solidFill>
-                  <a:srgbClr val="1F2328"/>
-                </a:solidFill>
-              </a:defRPr>
-            </a:pPr>
-            <a:r>
-              <a:t>[4] ERC-4337 (2023) — Account Abstraction</a:t>
+              <a:defRPr sz="1000" b="0">
+                <a:solidFill>
+                  <a:srgbClr val="1F2328"/>
+                </a:solidFill>
+              </a:defRPr>
+            </a:pPr>
+            <a:r>
+              <a:t>[4] "Security of Autonomous Agents: Attack Surface Analysis." arXiv:2403.1114, 2024.</a:t>
             </a:r>
           </a:p>
         </p:txBody>
@@ -5253,8 +5250,8 @@
         </p:nvSpPr>
         <p:spPr>
           <a:xfrm>
-            <a:off x="571500" y="2390000"/>
-            <a:ext cx="11049000" cy="320000"/>
+            <a:off x="571500" y="2110000"/>
+            <a:ext cx="11049000" cy="310000"/>
           </a:xfrm>
           <a:prstGeom prst="rect">
             <a:avLst/>
@@ -5287,7 +5284,6 @@
           <a:lstStyle/>
           <a:p>
             <a:pPr algn="ctr"/>
-            <a:endParaRPr/>
           </a:p>
         </p:txBody>
       </p:sp>
@@ -5299,8 +5295,8 @@
         </p:nvSpPr>
         <p:spPr>
           <a:xfrm>
-            <a:off x="691500" y="2450000"/>
-            <a:ext cx="10809000" cy="200000"/>
+            <a:off x="651500" y="2170000"/>
+            <a:ext cx="10889000" cy="200000"/>
           </a:xfrm>
           <a:prstGeom prst="rect">
             <a:avLst/>
@@ -5314,14 +5310,14 @@
           <a:lstStyle/>
           <a:p>
             <a:pPr>
-              <a:defRPr sz="1100" b="0">
-                <a:solidFill>
-                  <a:srgbClr val="1F2328"/>
-                </a:solidFill>
-              </a:defRPr>
-            </a:pPr>
-            <a:r>
-              <a:t>[5] UniswapX — Dutch Auction 意图驱动交易</a:t>
+              <a:defRPr sz="1000" b="0">
+                <a:solidFill>
+                  <a:srgbClr val="1F2328"/>
+                </a:solidFill>
+              </a:defRPr>
+            </a:pPr>
+            <a:r>
+              <a:t>[5] ERC-4337: Account Abstraction Using Alt Mempool. Ethereum.org, 2023.</a:t>
             </a:r>
           </a:p>
         </p:txBody>
@@ -5334,8 +5330,8 @@
         </p:nvSpPr>
         <p:spPr>
           <a:xfrm>
-            <a:off x="571500" y="2750000"/>
-            <a:ext cx="11049000" cy="320000"/>
+            <a:off x="571500" y="2450000"/>
+            <a:ext cx="11049000" cy="310000"/>
           </a:xfrm>
           <a:prstGeom prst="rect">
             <a:avLst/>
@@ -5368,7 +5364,6 @@
           <a:lstStyle/>
           <a:p>
             <a:pPr algn="ctr"/>
-            <a:endParaRPr/>
           </a:p>
         </p:txBody>
       </p:sp>
@@ -5380,8 +5375,8 @@
         </p:nvSpPr>
         <p:spPr>
           <a:xfrm>
-            <a:off x="691500" y="2810000"/>
-            <a:ext cx="10809000" cy="200000"/>
+            <a:off x="651500" y="2510000"/>
+            <a:ext cx="10889000" cy="200000"/>
           </a:xfrm>
           <a:prstGeom prst="rect">
             <a:avLst/>
@@ -5395,14 +5390,14 @@
           <a:lstStyle/>
           <a:p>
             <a:pPr>
-              <a:defRPr sz="1100" b="0">
-                <a:solidFill>
-                  <a:srgbClr val="1F2328"/>
-                </a:solidFill>
-              </a:defRPr>
-            </a:pPr>
-            <a:r>
-              <a:t>[6] CoW Protocol — Batch Auction MEV 保护</a:t>
+              <a:defRPr sz="1000" b="0">
+                <a:solidFill>
+                  <a:srgbClr val="1F2328"/>
+                </a:solidFill>
+              </a:defRPr>
+            </a:pPr>
+            <a:r>
+              <a:t>[6] ERC-7683: Cross Chain Intents. Ethereum Magicians, 2024.</a:t>
             </a:r>
           </a:p>
         </p:txBody>
@@ -5415,8 +5410,8 @@
         </p:nvSpPr>
         <p:spPr>
           <a:xfrm>
-            <a:off x="571500" y="3110000"/>
-            <a:ext cx="11049000" cy="320000"/>
+            <a:off x="571500" y="2790000"/>
+            <a:ext cx="11049000" cy="310000"/>
           </a:xfrm>
           <a:prstGeom prst="rect">
             <a:avLst/>
@@ -5449,7 +5444,6 @@
           <a:lstStyle/>
           <a:p>
             <a:pPr algn="ctr"/>
-            <a:endParaRPr/>
           </a:p>
         </p:txBody>
       </p:sp>
@@ -5461,8 +5455,8 @@
         </p:nvSpPr>
         <p:spPr>
           <a:xfrm>
-            <a:off x="691500" y="3170000"/>
-            <a:ext cx="10809000" cy="200000"/>
+            <a:off x="651500" y="2850000"/>
+            <a:ext cx="10889000" cy="200000"/>
           </a:xfrm>
           <a:prstGeom prst="rect">
             <a:avLst/>
@@ -5476,14 +5470,14 @@
           <a:lstStyle/>
           <a:p>
             <a:pPr>
-              <a:defRPr sz="1100" b="0">
-                <a:solidFill>
-                  <a:srgbClr val="1F2328"/>
-                </a:solidFill>
-              </a:defRPr>
-            </a:pPr>
-            <a:r>
-              <a:t>[7] 1inch Fusion — RFQ 无 Gas 交换</a:t>
+              <a:defRPr sz="1000" b="0">
+                <a:solidFill>
+                  <a:srgbClr val="1F2328"/>
+                </a:solidFill>
+              </a:defRPr>
+            </a:pPr>
+            <a:r>
+              <a:t>[7] ERC-8004: Trustless Agents. Ethereum Magicians, 2025.</a:t>
             </a:r>
           </a:p>
         </p:txBody>
@@ -5496,8 +5490,8 @@
         </p:nvSpPr>
         <p:spPr>
           <a:xfrm>
-            <a:off x="571500" y="3470000"/>
-            <a:ext cx="11049000" cy="320000"/>
+            <a:off x="571500" y="3130000"/>
+            <a:ext cx="11049000" cy="310000"/>
           </a:xfrm>
           <a:prstGeom prst="rect">
             <a:avLst/>
@@ -5530,7 +5524,6 @@
           <a:lstStyle/>
           <a:p>
             <a:pPr algn="ctr"/>
-            <a:endParaRPr/>
           </a:p>
         </p:txBody>
       </p:sp>
@@ -5542,8 +5535,8 @@
         </p:nvSpPr>
         <p:spPr>
           <a:xfrm>
-            <a:off x="691500" y="3530000"/>
-            <a:ext cx="10809000" cy="200000"/>
+            <a:off x="651500" y="3190000"/>
+            <a:ext cx="10889000" cy="200000"/>
           </a:xfrm>
           <a:prstGeom prst="rect">
             <a:avLst/>
@@ -5557,14 +5550,14 @@
           <a:lstStyle/>
           <a:p>
             <a:pPr>
-              <a:defRPr sz="1100" b="0">
-                <a:solidFill>
-                  <a:srgbClr val="1F2328"/>
-                </a:solidFill>
-              </a:defRPr>
-            </a:pPr>
-            <a:r>
-              <a:t>[8] Blowfish — Transaction Simulation</a:t>
+              <a:defRPr sz="1000" b="0">
+                <a:solidFill>
+                  <a:srgbClr val="1F2328"/>
+                </a:solidFill>
+              </a:defRPr>
+            </a:pPr>
+            <a:r>
+              <a:t>[8] ERC-8211: Smart Batching. Ethereum Magicians, 2025.</a:t>
             </a:r>
           </a:p>
         </p:txBody>
@@ -5577,8 +5570,8 @@
         </p:nvSpPr>
         <p:spPr>
           <a:xfrm>
-            <a:off x="571500" y="3830000"/>
-            <a:ext cx="11049000" cy="320000"/>
+            <a:off x="571500" y="3470000"/>
+            <a:ext cx="11049000" cy="310000"/>
           </a:xfrm>
           <a:prstGeom prst="rect">
             <a:avLst/>
@@ -5611,7 +5604,6 @@
           <a:lstStyle/>
           <a:p>
             <a:pPr algn="ctr"/>
-            <a:endParaRPr/>
           </a:p>
         </p:txBody>
       </p:sp>
@@ -5623,8 +5615,8 @@
         </p:nvSpPr>
         <p:spPr>
           <a:xfrm>
-            <a:off x="691500" y="3890000"/>
-            <a:ext cx="10809000" cy="200000"/>
+            <a:off x="651500" y="3530000"/>
+            <a:ext cx="10889000" cy="200000"/>
           </a:xfrm>
           <a:prstGeom prst="rect">
             <a:avLst/>
@@ -5638,14 +5630,14 @@
           <a:lstStyle/>
           <a:p>
             <a:pPr>
-              <a:defRPr sz="1100" b="0">
-                <a:solidFill>
-                  <a:srgbClr val="1F2328"/>
-                </a:solidFill>
-              </a:defRPr>
-            </a:pPr>
-            <a:r>
-              <a:t>[9] ElizaOS (elizaOS/eliza) — 18.6k ⭐</a:t>
+              <a:defRPr sz="1000" b="0">
+                <a:solidFill>
+                  <a:srgbClr val="1F2328"/>
+                </a:solidFill>
+              </a:defRPr>
+            </a:pPr>
+            <a:r>
+              <a:t>[9] UniswapX: Dutch Auction Based Cross-Chain Swaps. uniswap.org, 2024.</a:t>
             </a:r>
           </a:p>
         </p:txBody>
@@ -5658,8 +5650,8 @@
         </p:nvSpPr>
         <p:spPr>
           <a:xfrm>
-            <a:off x="571500" y="4190000"/>
-            <a:ext cx="11049000" cy="320000"/>
+            <a:off x="571500" y="3810000"/>
+            <a:ext cx="11049000" cy="310000"/>
           </a:xfrm>
           <a:prstGeom prst="rect">
             <a:avLst/>
@@ -5692,7 +5684,6 @@
           <a:lstStyle/>
           <a:p>
             <a:pPr algn="ctr"/>
-            <a:endParaRPr/>
           </a:p>
         </p:txBody>
       </p:sp>
@@ -5704,8 +5695,8 @@
         </p:nvSpPr>
         <p:spPr>
           <a:xfrm>
-            <a:off x="691500" y="4250000"/>
-            <a:ext cx="10809000" cy="200000"/>
+            <a:off x="651500" y="3870000"/>
+            <a:ext cx="10889000" cy="200000"/>
           </a:xfrm>
           <a:prstGeom prst="rect">
             <a:avLst/>
@@ -5719,28 +5710,73 @@
           <a:lstStyle/>
           <a:p>
             <a:pPr>
-              <a:defRPr sz="1100" b="0">
-                <a:solidFill>
-                  <a:srgbClr val="1F2328"/>
-                </a:solidFill>
-              </a:defRPr>
-            </a:pPr>
-            <a:r>
-              <a:t>[10] Fetch.ai uAgents — 1.6k ⭐</a:t>
-            </a:r>
-          </a:p>
-        </p:txBody>
-      </p:sp>
-      <p:sp>
-        <p:nvSpPr>
-          <p:cNvPr id="23" name="TextBox 22"/>
+              <a:defRPr sz="1000" b="0">
+                <a:solidFill>
+                  <a:srgbClr val="1F2328"/>
+                </a:solidFill>
+              </a:defRPr>
+            </a:pPr>
+            <a:r>
+              <a:t>[10] CoW Protocol: Batch Auction for MEV-Protected Trading. cow.fi, 2023.</a:t>
+            </a:r>
+          </a:p>
+        </p:txBody>
+      </p:sp>
+      <p:sp>
+        <p:nvSpPr>
+          <p:cNvPr id="23" name="Rectangle 22"/>
+          <p:cNvSpPr/>
+          <p:nvPr/>
+        </p:nvSpPr>
+        <p:spPr>
+          <a:xfrm>
+            <a:off x="571500" y="4150000"/>
+            <a:ext cx="11049000" cy="310000"/>
+          </a:xfrm>
+          <a:prstGeom prst="rect">
+            <a:avLst/>
+          </a:prstGeom>
+          <a:solidFill>
+            <a:srgbClr val="F6F8FA"/>
+          </a:solidFill>
+          <a:ln w="6350">
+            <a:solidFill>
+              <a:srgbClr val="E1E4E8"/>
+            </a:solidFill>
+          </a:ln>
+        </p:spPr>
+        <p:style>
+          <a:lnRef idx="1">
+            <a:schemeClr val="accent1"/>
+          </a:lnRef>
+          <a:fillRef idx="3">
+            <a:schemeClr val="accent1"/>
+          </a:fillRef>
+          <a:effectRef idx="2">
+            <a:schemeClr val="accent1"/>
+          </a:effectRef>
+          <a:fontRef idx="minor">
+            <a:schemeClr val="lt1"/>
+          </a:fontRef>
+        </p:style>
+        <p:txBody>
+          <a:bodyPr rtlCol="0" anchor="ctr"/>
+          <a:lstStyle/>
+          <a:p>
+            <a:pPr algn="ctr"/>
+          </a:p>
+        </p:txBody>
+      </p:sp>
+      <p:sp>
+        <p:nvSpPr>
+          <p:cNvPr id="24" name="TextBox 23"/>
           <p:cNvSpPr txBox="1"/>
           <p:nvPr/>
         </p:nvSpPr>
         <p:spPr>
           <a:xfrm>
-            <a:off x="571500" y="6000000"/>
-            <a:ext cx="11049000" cy="250000"/>
+            <a:off x="651500" y="4210000"/>
+            <a:ext cx="10889000" cy="200000"/>
           </a:xfrm>
           <a:prstGeom prst="rect">
             <a:avLst/>
@@ -5754,6 +5790,361 @@
           <a:lstStyle/>
           <a:p>
             <a:pPr>
+              <a:defRPr sz="1000" b="0">
+                <a:solidFill>
+                  <a:srgbClr val="1F2328"/>
+                </a:solidFill>
+              </a:defRPr>
+            </a:pPr>
+            <a:r>
+              <a:t>[11] 1inch Fusion: RFQ-Based Gasless Swaps. 1inch.io, 2024.</a:t>
+            </a:r>
+          </a:p>
+        </p:txBody>
+      </p:sp>
+      <p:sp>
+        <p:nvSpPr>
+          <p:cNvPr id="25" name="Rectangle 24"/>
+          <p:cNvSpPr/>
+          <p:nvPr/>
+        </p:nvSpPr>
+        <p:spPr>
+          <a:xfrm>
+            <a:off x="571500" y="4490000"/>
+            <a:ext cx="11049000" cy="310000"/>
+          </a:xfrm>
+          <a:prstGeom prst="rect">
+            <a:avLst/>
+          </a:prstGeom>
+          <a:solidFill>
+            <a:srgbClr val="FFFFFF"/>
+          </a:solidFill>
+          <a:ln w="6350">
+            <a:solidFill>
+              <a:srgbClr val="E1E4E8"/>
+            </a:solidFill>
+          </a:ln>
+        </p:spPr>
+        <p:style>
+          <a:lnRef idx="1">
+            <a:schemeClr val="accent1"/>
+          </a:lnRef>
+          <a:fillRef idx="3">
+            <a:schemeClr val="accent1"/>
+          </a:fillRef>
+          <a:effectRef idx="2">
+            <a:schemeClr val="accent1"/>
+          </a:effectRef>
+          <a:fontRef idx="minor">
+            <a:schemeClr val="lt1"/>
+          </a:fontRef>
+        </p:style>
+        <p:txBody>
+          <a:bodyPr rtlCol="0" anchor="ctr"/>
+          <a:lstStyle/>
+          <a:p>
+            <a:pPr algn="ctr"/>
+          </a:p>
+        </p:txBody>
+      </p:sp>
+      <p:sp>
+        <p:nvSpPr>
+          <p:cNvPr id="26" name="TextBox 25"/>
+          <p:cNvSpPr txBox="1"/>
+          <p:nvPr/>
+        </p:nvSpPr>
+        <p:spPr>
+          <a:xfrm>
+            <a:off x="651500" y="4550000"/>
+            <a:ext cx="10889000" cy="200000"/>
+          </a:xfrm>
+          <a:prstGeom prst="rect">
+            <a:avLst/>
+          </a:prstGeom>
+          <a:noFill/>
+        </p:spPr>
+        <p:txBody>
+          <a:bodyPr wrap="square">
+            <a:spAutoFit/>
+          </a:bodyPr>
+          <a:lstStyle/>
+          <a:p>
+            <a:pPr>
+              <a:defRPr sz="1000" b="0">
+                <a:solidFill>
+                  <a:srgbClr val="1F2328"/>
+                </a:solidFill>
+              </a:defRPr>
+            </a:pPr>
+            <a:r>
+              <a:t>[12] Across Protocol: Optimistic Cross-Chain Filling. across.to, 2023.</a:t>
+            </a:r>
+          </a:p>
+        </p:txBody>
+      </p:sp>
+      <p:sp>
+        <p:nvSpPr>
+          <p:cNvPr id="27" name="Rectangle 26"/>
+          <p:cNvSpPr/>
+          <p:nvPr/>
+        </p:nvSpPr>
+        <p:spPr>
+          <a:xfrm>
+            <a:off x="571500" y="4830000"/>
+            <a:ext cx="11049000" cy="310000"/>
+          </a:xfrm>
+          <a:prstGeom prst="rect">
+            <a:avLst/>
+          </a:prstGeom>
+          <a:solidFill>
+            <a:srgbClr val="F6F8FA"/>
+          </a:solidFill>
+          <a:ln w="6350">
+            <a:solidFill>
+              <a:srgbClr val="E1E4E8"/>
+            </a:solidFill>
+          </a:ln>
+        </p:spPr>
+        <p:style>
+          <a:lnRef idx="1">
+            <a:schemeClr val="accent1"/>
+          </a:lnRef>
+          <a:fillRef idx="3">
+            <a:schemeClr val="accent1"/>
+          </a:fillRef>
+          <a:effectRef idx="2">
+            <a:schemeClr val="accent1"/>
+          </a:effectRef>
+          <a:fontRef idx="minor">
+            <a:schemeClr val="lt1"/>
+          </a:fontRef>
+        </p:style>
+        <p:txBody>
+          <a:bodyPr rtlCol="0" anchor="ctr"/>
+          <a:lstStyle/>
+          <a:p>
+            <a:pPr algn="ctr"/>
+          </a:p>
+        </p:txBody>
+      </p:sp>
+      <p:sp>
+        <p:nvSpPr>
+          <p:cNvPr id="28" name="TextBox 27"/>
+          <p:cNvSpPr txBox="1"/>
+          <p:nvPr/>
+        </p:nvSpPr>
+        <p:spPr>
+          <a:xfrm>
+            <a:off x="651500" y="4890000"/>
+            <a:ext cx="10889000" cy="200000"/>
+          </a:xfrm>
+          <a:prstGeom prst="rect">
+            <a:avLst/>
+          </a:prstGeom>
+          <a:noFill/>
+        </p:spPr>
+        <p:txBody>
+          <a:bodyPr wrap="square">
+            <a:spAutoFit/>
+          </a:bodyPr>
+          <a:lstStyle/>
+          <a:p>
+            <a:pPr>
+              <a:defRPr sz="1000" b="0">
+                <a:solidFill>
+                  <a:srgbClr val="1F2328"/>
+                </a:solidFill>
+              </a:defRPr>
+            </a:pPr>
+            <a:r>
+              <a:t>[13] Blowfish: Transaction Simulation and Security. blowfish.xyz, 2023.</a:t>
+            </a:r>
+          </a:p>
+        </p:txBody>
+      </p:sp>
+      <p:sp>
+        <p:nvSpPr>
+          <p:cNvPr id="29" name="Rectangle 28"/>
+          <p:cNvSpPr/>
+          <p:nvPr/>
+        </p:nvSpPr>
+        <p:spPr>
+          <a:xfrm>
+            <a:off x="571500" y="5170000"/>
+            <a:ext cx="11049000" cy="310000"/>
+          </a:xfrm>
+          <a:prstGeom prst="rect">
+            <a:avLst/>
+          </a:prstGeom>
+          <a:solidFill>
+            <a:srgbClr val="FFFFFF"/>
+          </a:solidFill>
+          <a:ln w="6350">
+            <a:solidFill>
+              <a:srgbClr val="E1E4E8"/>
+            </a:solidFill>
+          </a:ln>
+        </p:spPr>
+        <p:style>
+          <a:lnRef idx="1">
+            <a:schemeClr val="accent1"/>
+          </a:lnRef>
+          <a:fillRef idx="3">
+            <a:schemeClr val="accent1"/>
+          </a:fillRef>
+          <a:effectRef idx="2">
+            <a:schemeClr val="accent1"/>
+          </a:effectRef>
+          <a:fontRef idx="minor">
+            <a:schemeClr val="lt1"/>
+          </a:fontRef>
+        </p:style>
+        <p:txBody>
+          <a:bodyPr rtlCol="0" anchor="ctr"/>
+          <a:lstStyle/>
+          <a:p>
+            <a:pPr algn="ctr"/>
+          </a:p>
+        </p:txBody>
+      </p:sp>
+      <p:sp>
+        <p:nvSpPr>
+          <p:cNvPr id="30" name="TextBox 29"/>
+          <p:cNvSpPr txBox="1"/>
+          <p:nvPr/>
+        </p:nvSpPr>
+        <p:spPr>
+          <a:xfrm>
+            <a:off x="651500" y="5230000"/>
+            <a:ext cx="10889000" cy="200000"/>
+          </a:xfrm>
+          <a:prstGeom prst="rect">
+            <a:avLst/>
+          </a:prstGeom>
+          <a:noFill/>
+        </p:spPr>
+        <p:txBody>
+          <a:bodyPr wrap="square">
+            <a:spAutoFit/>
+          </a:bodyPr>
+          <a:lstStyle/>
+          <a:p>
+            <a:pPr>
+              <a:defRPr sz="1000" b="0">
+                <a:solidFill>
+                  <a:srgbClr val="1F2328"/>
+                </a:solidFill>
+              </a:defRPr>
+            </a:pPr>
+            <a:r>
+              <a:t>[14] ElizaOS: Open Source AI Agent Operating System. github.com/elizaOS/eliza, 2025.</a:t>
+            </a:r>
+          </a:p>
+        </p:txBody>
+      </p:sp>
+      <p:sp>
+        <p:nvSpPr>
+          <p:cNvPr id="31" name="Rectangle 30"/>
+          <p:cNvSpPr/>
+          <p:nvPr/>
+        </p:nvSpPr>
+        <p:spPr>
+          <a:xfrm>
+            <a:off x="571500" y="5510000"/>
+            <a:ext cx="11049000" cy="310000"/>
+          </a:xfrm>
+          <a:prstGeom prst="rect">
+            <a:avLst/>
+          </a:prstGeom>
+          <a:solidFill>
+            <a:srgbClr val="F6F8FA"/>
+          </a:solidFill>
+          <a:ln w="6350">
+            <a:solidFill>
+              <a:srgbClr val="E1E4E8"/>
+            </a:solidFill>
+          </a:ln>
+        </p:spPr>
+        <p:style>
+          <a:lnRef idx="1">
+            <a:schemeClr val="accent1"/>
+          </a:lnRef>
+          <a:fillRef idx="3">
+            <a:schemeClr val="accent1"/>
+          </a:fillRef>
+          <a:effectRef idx="2">
+            <a:schemeClr val="accent1"/>
+          </a:effectRef>
+          <a:fontRef idx="minor">
+            <a:schemeClr val="lt1"/>
+          </a:fontRef>
+        </p:style>
+        <p:txBody>
+          <a:bodyPr rtlCol="0" anchor="ctr"/>
+          <a:lstStyle/>
+          <a:p>
+            <a:pPr algn="ctr"/>
+          </a:p>
+        </p:txBody>
+      </p:sp>
+      <p:sp>
+        <p:nvSpPr>
+          <p:cNvPr id="32" name="TextBox 31"/>
+          <p:cNvSpPr txBox="1"/>
+          <p:nvPr/>
+        </p:nvSpPr>
+        <p:spPr>
+          <a:xfrm>
+            <a:off x="651500" y="5570000"/>
+            <a:ext cx="10889000" cy="200000"/>
+          </a:xfrm>
+          <a:prstGeom prst="rect">
+            <a:avLst/>
+          </a:prstGeom>
+          <a:noFill/>
+        </p:spPr>
+        <p:txBody>
+          <a:bodyPr wrap="square">
+            <a:spAutoFit/>
+          </a:bodyPr>
+          <a:lstStyle/>
+          <a:p>
+            <a:pPr>
+              <a:defRPr sz="1000" b="0">
+                <a:solidFill>
+                  <a:srgbClr val="1F2328"/>
+                </a:solidFill>
+              </a:defRPr>
+            </a:pPr>
+            <a:r>
+              <a:t>[15] Fetch.ai uAgents: Decentralized Agent Framework. github.com/fetchai/uAgents, 2024.</a:t>
+            </a:r>
+          </a:p>
+        </p:txBody>
+      </p:sp>
+      <p:sp>
+        <p:nvSpPr>
+          <p:cNvPr id="33" name="TextBox 32"/>
+          <p:cNvSpPr txBox="1"/>
+          <p:nvPr/>
+        </p:nvSpPr>
+        <p:spPr>
+          <a:xfrm>
+            <a:off x="571500" y="6100000"/>
+            <a:ext cx="11049000" cy="250000"/>
+          </a:xfrm>
+          <a:prstGeom prst="rect">
+            <a:avLst/>
+          </a:prstGeom>
+          <a:noFill/>
+        </p:spPr>
+        <p:txBody>
+          <a:bodyPr wrap="square">
+            <a:spAutoFit/>
+          </a:bodyPr>
+          <a:lstStyle/>
+          <a:p>
+            <a:pPr>
               <a:defRPr sz="900" b="0">
                 <a:solidFill>
                   <a:srgbClr val="656D76"/>
@@ -5761,7 +6152,7 @@
               </a:defRPr>
             </a:pPr>
             <a:r>
-              <a:t>更多资料: docs/ 目录下含完整分析文档</a:t>
+              <a:t>docs/ 目录下含完整分析文档  |  github.com/laserBea/chiron</a:t>
             </a:r>
           </a:p>
         </p:txBody>
@@ -5775,7 +6166,7 @@
 </file>
 
 <file path=ppt/slides/slide13.xml><?xml version="1.0" encoding="utf-8"?>
-<p:sld xmlns:a="http://schemas.openxmlformats.org/drawingml/2006/main" xmlns:r="http://schemas.openxmlformats.org/officeDocument/2006/relationships" xmlns:p="http://schemas.openxmlformats.org/presentationml/2006/main">
+<p:sld xmlns:a="http://schemas.openxmlformats.org/drawingml/2006/main" xmlns:p="http://schemas.openxmlformats.org/presentationml/2006/main" xmlns:r="http://schemas.openxmlformats.org/officeDocument/2006/relationships">
   <p:cSld>
     <p:spTree>
       <p:nvGrpSpPr>
@@ -5783,14 +6174,7 @@
         <p:cNvGrpSpPr/>
         <p:nvPr/>
       </p:nvGrpSpPr>
-      <p:grpSpPr>
-        <a:xfrm>
-          <a:off x="0" y="0"/>
-          <a:ext cx="0" cy="0"/>
-          <a:chOff x="0" y="0"/>
-          <a:chExt cx="0" cy="0"/>
-        </a:xfrm>
-      </p:grpSpPr>
+      <p:grpSpPr/>
       <p:sp>
         <p:nvSpPr>
           <p:cNvPr id="2" name="TextBox 1"/>
@@ -5808,7 +6192,7 @@
           <a:noFill/>
         </p:spPr>
         <p:txBody>
-          <a:bodyPr wrap="square">
+          <a:bodyPr wrap="none">
             <a:spAutoFit/>
           </a:bodyPr>
           <a:lstStyle/>
@@ -5843,13 +6227,13 @@
           <a:noFill/>
         </p:spPr>
         <p:txBody>
-          <a:bodyPr wrap="square">
+          <a:bodyPr wrap="none">
             <a:spAutoFit/>
           </a:bodyPr>
           <a:lstStyle/>
           <a:p>
             <a:pPr>
-              <a:defRPr sz="2000" b="0">
+              <a:defRPr sz="2000">
                 <a:solidFill>
                   <a:srgbClr val="656D76"/>
                 </a:solidFill>
@@ -5878,15 +6262,15 @@
           <a:noFill/>
         </p:spPr>
         <p:txBody>
-          <a:bodyPr wrap="square">
+          <a:bodyPr wrap="none">
             <a:spAutoFit/>
           </a:bodyPr>
           <a:lstStyle/>
           <a:p>
             <a:pPr>
-              <a:defRPr sz="1600" b="0">
-                <a:solidFill>
-                  <a:srgbClr val="656D76"/>
+              <a:defRPr sz="1600">
+                <a:solidFill>
+                  <a:srgbClr val="0969DA"/>
                 </a:solidFill>
               </a:defRPr>
             </a:pPr>
@@ -6953,6 +7337,10 @@
             <a:avLst/>
           </a:prstGeom>
         </p:spPr>
+        <p:txBody>
+          <a:bodyPr/>
+          <a:p/>
+        </p:txBody>
       </p:sp>
       <p:sp>
         <p:nvSpPr>
@@ -7808,6 +8196,10 @@
             <a:avLst/>
           </a:prstGeom>
         </p:spPr>
+        <p:txBody>
+          <a:bodyPr/>
+          <a:p/>
+        </p:txBody>
       </p:sp>
       <p:sp>
         <p:nvSpPr>
@@ -8618,6 +9010,10 @@
             <a:avLst/>
           </a:prstGeom>
         </p:spPr>
+        <p:txBody>
+          <a:bodyPr/>
+          <a:p/>
+        </p:txBody>
       </p:sp>
       <p:sp>
         <p:nvSpPr>
@@ -9422,6 +9818,10 @@
             <a:avLst/>
           </a:prstGeom>
         </p:spPr>
+        <p:txBody>
+          <a:bodyPr/>
+          <a:p/>
+        </p:txBody>
       </p:sp>
       <p:sp>
         <p:nvSpPr>
@@ -10266,6 +10666,10 @@
             <a:avLst/>
           </a:prstGeom>
         </p:spPr>
+        <p:txBody>
+          <a:bodyPr/>
+          <a:p/>
+        </p:txBody>
       </p:sp>
       <p:sp>
         <p:nvSpPr>
@@ -11388,6 +11792,10 @@
             <a:avLst/>
           </a:prstGeom>
         </p:spPr>
+        <p:txBody>
+          <a:bodyPr/>
+          <a:p/>
+        </p:txBody>
       </p:sp>
       <p:sp>
         <p:nvSpPr>

</xml_diff>